<commit_message>
Put the defensibility argument back on the moat slide
The slide showed the artifact and not the reason it holds. It had a loop diagram,
two counts and a closing line, but nothing answering the question a listener
actually asks: could someone else not just build the same library?

The three reasons that used to sit in a side panel now close the slide as a band
across the full width — earned not bought, it compounds, capital cannot copy it.
No panel, so nothing to lose in a round trip, and the width freed earlier is what
makes room for them.

Cut the sentence about writing patterns and failures back into the library: the
Build / Capture / Reuse diagram directly above already says it, sub-labels and
all. The closing "that loop is the moat" line goes too, since the three reasons
now do that work and the title already names the moat.

Co-Authored-By: Claude Opus 5 <noreply@anthropic.com>
Claude-Session: https://claude.ai/code/session_01F4vsvBCtTptziT9dDHSPcr
</commit_message>
<xml_diff>
--- a/decks/Pitch_Deck_AthenaRun_v4.pptx
+++ b/decks/Pitch_Deck_AthenaRun_v4.pptx
@@ -10926,7 +10926,7 @@
         <p:spPr>
           <a:xfrm>
             <a:off x="694944" y="1280160"/>
-            <a:ext cx="10789920" cy="219456"/>
+            <a:ext cx="10789920" cy="201168"/>
           </a:xfrm>
           <a:prstGeom prst="rect">
             <a:avLst/>
@@ -10960,7 +10960,7 @@
         </p:nvSpPr>
         <p:spPr>
           <a:xfrm>
-            <a:off x="694944" y="1828800"/>
+            <a:off x="694944" y="1773936"/>
             <a:ext cx="4572000" cy="164592"/>
           </a:xfrm>
           <a:prstGeom prst="rect">
@@ -10995,8 +10995,8 @@
         </p:nvSpPr>
         <p:spPr>
           <a:xfrm>
-            <a:off x="694944" y="2103120"/>
-            <a:ext cx="3377184" cy="914400"/>
+            <a:off x="694944" y="2011680"/>
+            <a:ext cx="3377184" cy="896112"/>
           </a:xfrm>
           <a:prstGeom prst="rect">
             <a:avLst/>
@@ -11027,7 +11027,7 @@
         </p:nvSpPr>
         <p:spPr>
           <a:xfrm>
-            <a:off x="694944" y="2322576"/>
+            <a:off x="694944" y="2212848"/>
             <a:ext cx="3377184" cy="256032"/>
           </a:xfrm>
           <a:prstGeom prst="rect">
@@ -11062,7 +11062,7 @@
         </p:nvSpPr>
         <p:spPr>
           <a:xfrm>
-            <a:off x="694944" y="2679192"/>
+            <a:off x="694944" y="2560320"/>
             <a:ext cx="3377184" cy="155448"/>
           </a:xfrm>
           <a:prstGeom prst="rect">
@@ -11097,7 +11097,7 @@
         </p:nvSpPr>
         <p:spPr>
           <a:xfrm rot="5400000">
-            <a:off x="4191000" y="2505456"/>
+            <a:off x="4191000" y="2404872"/>
             <a:ext cx="91440" cy="109728"/>
           </a:xfrm>
           <a:prstGeom prst="triangle">
@@ -11127,8 +11127,8 @@
         </p:nvSpPr>
         <p:spPr>
           <a:xfrm>
-            <a:off x="4401312" y="2103120"/>
-            <a:ext cx="3377184" cy="914400"/>
+            <a:off x="4401312" y="2011680"/>
+            <a:ext cx="3377184" cy="896112"/>
           </a:xfrm>
           <a:prstGeom prst="rect">
             <a:avLst/>
@@ -11159,7 +11159,7 @@
         </p:nvSpPr>
         <p:spPr>
           <a:xfrm>
-            <a:off x="4401312" y="2322576"/>
+            <a:off x="4401312" y="2212848"/>
             <a:ext cx="3377184" cy="256032"/>
           </a:xfrm>
           <a:prstGeom prst="rect">
@@ -11194,7 +11194,7 @@
         </p:nvSpPr>
         <p:spPr>
           <a:xfrm>
-            <a:off x="4401312" y="2679192"/>
+            <a:off x="4401312" y="2560320"/>
             <a:ext cx="3377184" cy="155448"/>
           </a:xfrm>
           <a:prstGeom prst="rect">
@@ -11229,7 +11229,7 @@
         </p:nvSpPr>
         <p:spPr>
           <a:xfrm rot="5400000">
-            <a:off x="7897368" y="2505456"/>
+            <a:off x="7897368" y="2404872"/>
             <a:ext cx="91440" cy="109728"/>
           </a:xfrm>
           <a:prstGeom prst="triangle">
@@ -11259,8 +11259,8 @@
         </p:nvSpPr>
         <p:spPr>
           <a:xfrm>
-            <a:off x="8107680" y="2103120"/>
-            <a:ext cx="3377184" cy="914400"/>
+            <a:off x="8107680" y="2011680"/>
+            <a:ext cx="3377184" cy="896112"/>
           </a:xfrm>
           <a:prstGeom prst="rect">
             <a:avLst/>
@@ -11291,7 +11291,7 @@
         </p:nvSpPr>
         <p:spPr>
           <a:xfrm>
-            <a:off x="8107680" y="2322576"/>
+            <a:off x="8107680" y="2212848"/>
             <a:ext cx="3377184" cy="256032"/>
           </a:xfrm>
           <a:prstGeom prst="rect">
@@ -11326,7 +11326,7 @@
         </p:nvSpPr>
         <p:spPr>
           <a:xfrm>
-            <a:off x="8107680" y="2679192"/>
+            <a:off x="8107680" y="2560320"/>
             <a:ext cx="3377184" cy="155448"/>
           </a:xfrm>
           <a:prstGeom prst="rect">
@@ -11361,8 +11361,8 @@
         </p:nvSpPr>
         <p:spPr>
           <a:xfrm>
-            <a:off x="9796272" y="3017520"/>
-            <a:ext cx="10973" cy="329184"/>
+            <a:off x="9796272" y="2907792"/>
+            <a:ext cx="10973" cy="310896"/>
           </a:xfrm>
           <a:prstGeom prst="rect">
             <a:avLst/>
@@ -11391,7 +11391,7 @@
         </p:nvSpPr>
         <p:spPr>
           <a:xfrm>
-            <a:off x="2383536" y="3346704"/>
+            <a:off x="2383536" y="3218688"/>
             <a:ext cx="7412736" cy="10973"/>
           </a:xfrm>
           <a:prstGeom prst="rect">
@@ -11421,8 +11421,8 @@
         </p:nvSpPr>
         <p:spPr>
           <a:xfrm>
-            <a:off x="2383536" y="3145536"/>
-            <a:ext cx="10973" cy="201168"/>
+            <a:off x="2383536" y="3035808"/>
+            <a:ext cx="10973" cy="182880"/>
           </a:xfrm>
           <a:prstGeom prst="rect">
             <a:avLst/>
@@ -11451,7 +11451,7 @@
         </p:nvSpPr>
         <p:spPr>
           <a:xfrm>
-            <a:off x="2334158" y="3022092"/>
+            <a:off x="2334158" y="2912364"/>
             <a:ext cx="109728" cy="137160"/>
           </a:xfrm>
           <a:prstGeom prst="triangle">
@@ -11481,7 +11481,7 @@
         </p:nvSpPr>
         <p:spPr>
           <a:xfrm>
-            <a:off x="2383536" y="3456432"/>
+            <a:off x="2383536" y="3310128"/>
             <a:ext cx="7412736" cy="155448"/>
           </a:xfrm>
           <a:prstGeom prst="rect">
@@ -11510,48 +11510,13 @@
       </p:sp>
       <p:sp>
         <p:nvSpPr>
-          <p:cNvPr id="123" name="TextBox 123"/>
-          <p:cNvSpPr txBox="1"/>
-          <p:nvPr/>
-        </p:nvSpPr>
-        <p:spPr>
-          <a:xfrm>
-            <a:off x="694944" y="3785616"/>
-            <a:ext cx="10789920" cy="201168"/>
-          </a:xfrm>
-          <a:prstGeom prst="rect">
-            <a:avLst/>
-          </a:prstGeom>
-          <a:noFill/>
-        </p:spPr>
-        <p:txBody>
-          <a:bodyPr wrap="square" lIns="0" rIns="0" tIns="0" bIns="0" anchor="ctr">
-            <a:spAutoFit/>
-          </a:bodyPr>
-          <a:lstStyle/>
-          <a:p>
-            <a:pPr algn="l"/>
-            <a:r>
-              <a:rPr sz="1200" b="0">
-                <a:solidFill>
-                  <a:srgbClr val="9A9AA2"/>
-                </a:solidFill>
-                <a:latin typeface="Poppins"/>
-              </a:rPr>
-              <a:t>Every project writes validated patterns and documented failures back into the library. Every next build queries it first.</a:t>
-            </a:r>
-          </a:p>
-        </p:txBody>
-      </p:sp>
-      <p:sp>
-        <p:nvSpPr>
-          <p:cNvPr id="124" name="rect 124"/>
+          <p:cNvPr id="123" name="rect 123"/>
           <p:cNvSpPr/>
           <p:nvPr/>
         </p:nvSpPr>
         <p:spPr>
           <a:xfrm>
-            <a:off x="694944" y="4187952"/>
+            <a:off x="694944" y="3675888"/>
             <a:ext cx="10789920" cy="10973"/>
           </a:xfrm>
           <a:prstGeom prst="rect">
@@ -11575,13 +11540,13 @@
       </p:sp>
       <p:sp>
         <p:nvSpPr>
-          <p:cNvPr id="125" name="TextBox 125"/>
-          <p:cNvSpPr txBox="1"/>
-          <p:nvPr/>
-        </p:nvSpPr>
-        <p:spPr>
-          <a:xfrm>
-            <a:off x="694944" y="4352544"/>
+          <p:cNvPr id="124" name="TextBox 124"/>
+          <p:cNvSpPr txBox="1"/>
+          <p:nvPr/>
+        </p:nvSpPr>
+        <p:spPr>
+          <a:xfrm>
+            <a:off x="694944" y="3840480"/>
             <a:ext cx="4572000" cy="164592"/>
           </a:xfrm>
           <a:prstGeom prst="rect">
@@ -11610,14 +11575,14 @@
       </p:sp>
       <p:sp>
         <p:nvSpPr>
-          <p:cNvPr id="126" name="rect 126"/>
+          <p:cNvPr id="125" name="rect 125"/>
           <p:cNvSpPr/>
           <p:nvPr/>
         </p:nvSpPr>
         <p:spPr>
           <a:xfrm>
-            <a:off x="694944" y="4590288"/>
-            <a:ext cx="5230368" cy="1115568"/>
+            <a:off x="694944" y="4078224"/>
+            <a:ext cx="5230368" cy="1060704"/>
           </a:xfrm>
           <a:prstGeom prst="rect">
             <a:avLst/>
@@ -11642,14 +11607,49 @@
       </p:sp>
       <p:sp>
         <p:nvSpPr>
+          <p:cNvPr id="126" name="TextBox 126"/>
+          <p:cNvSpPr txBox="1"/>
+          <p:nvPr/>
+        </p:nvSpPr>
+        <p:spPr>
+          <a:xfrm>
+            <a:off x="969264" y="4279392"/>
+            <a:ext cx="4681728" cy="530352"/>
+          </a:xfrm>
+          <a:prstGeom prst="rect">
+            <a:avLst/>
+          </a:prstGeom>
+          <a:noFill/>
+        </p:spPr>
+        <p:txBody>
+          <a:bodyPr wrap="square" lIns="0" rIns="0" tIns="0" bIns="0" anchor="ctr">
+            <a:spAutoFit/>
+          </a:bodyPr>
+          <a:lstStyle/>
+          <a:p>
+            <a:pPr algn="l"/>
+            <a:r>
+              <a:rPr sz="3800" b="0">
+                <a:solidFill>
+                  <a:srgbClr val="ECECEE"/>
+                </a:solidFill>
+                <a:latin typeface="Poppins"/>
+              </a:rPr>
+              <a:t>Hundreds</a:t>
+            </a:r>
+          </a:p>
+        </p:txBody>
+      </p:sp>
+      <p:sp>
+        <p:nvSpPr>
           <p:cNvPr id="127" name="TextBox 127"/>
           <p:cNvSpPr txBox="1"/>
           <p:nvPr/>
         </p:nvSpPr>
         <p:spPr>
           <a:xfrm>
-            <a:off x="969264" y="4809744"/>
-            <a:ext cx="4681728" cy="530352"/>
+            <a:off x="969264" y="4846320"/>
+            <a:ext cx="4681728" cy="192024"/>
           </a:xfrm>
           <a:prstGeom prst="rect">
             <a:avLst/>
@@ -11664,47 +11664,12 @@
           <a:p>
             <a:pPr algn="l"/>
             <a:r>
-              <a:rPr sz="3800" b="0">
+              <a:rPr sz="1400" b="0">
                 <a:solidFill>
                   <a:srgbClr val="ECECEE"/>
                 </a:solidFill>
                 <a:latin typeface="Poppins"/>
               </a:rPr>
-              <a:t>Hundreds</a:t>
-            </a:r>
-          </a:p>
-        </p:txBody>
-      </p:sp>
-      <p:sp>
-        <p:nvSpPr>
-          <p:cNvPr id="128" name="TextBox 128"/>
-          <p:cNvSpPr txBox="1"/>
-          <p:nvPr/>
-        </p:nvSpPr>
-        <p:spPr>
-          <a:xfrm>
-            <a:off x="969264" y="5376672"/>
-            <a:ext cx="4681728" cy="192024"/>
-          </a:xfrm>
-          <a:prstGeom prst="rect">
-            <a:avLst/>
-          </a:prstGeom>
-          <a:noFill/>
-        </p:spPr>
-        <p:txBody>
-          <a:bodyPr wrap="square" lIns="0" rIns="0" tIns="0" bIns="0" anchor="ctr">
-            <a:spAutoFit/>
-          </a:bodyPr>
-          <a:lstStyle/>
-          <a:p>
-            <a:pPr algn="l"/>
-            <a:r>
-              <a:rPr sz="1400" b="0">
-                <a:solidFill>
-                  <a:srgbClr val="ECECEE"/>
-                </a:solidFill>
-                <a:latin typeface="Poppins"/>
-              </a:rPr>
               <a:t>validated patterns</a:t>
             </a:r>
           </a:p>
@@ -11712,14 +11677,14 @@
       </p:sp>
       <p:sp>
         <p:nvSpPr>
-          <p:cNvPr id="129" name="rect 129"/>
+          <p:cNvPr id="128" name="rect 128"/>
           <p:cNvSpPr/>
           <p:nvPr/>
         </p:nvSpPr>
         <p:spPr>
           <a:xfrm>
-            <a:off x="6254496" y="4590288"/>
-            <a:ext cx="5230368" cy="1115568"/>
+            <a:off x="6254496" y="4078224"/>
+            <a:ext cx="5230368" cy="1060704"/>
           </a:xfrm>
           <a:prstGeom prst="rect">
             <a:avLst/>
@@ -11744,14 +11709,49 @@
       </p:sp>
       <p:sp>
         <p:nvSpPr>
+          <p:cNvPr id="129" name="TextBox 129"/>
+          <p:cNvSpPr txBox="1"/>
+          <p:nvPr/>
+        </p:nvSpPr>
+        <p:spPr>
+          <a:xfrm>
+            <a:off x="6528816" y="4279392"/>
+            <a:ext cx="4681728" cy="530352"/>
+          </a:xfrm>
+          <a:prstGeom prst="rect">
+            <a:avLst/>
+          </a:prstGeom>
+          <a:noFill/>
+        </p:spPr>
+        <p:txBody>
+          <a:bodyPr wrap="square" lIns="0" rIns="0" tIns="0" bIns="0" anchor="ctr">
+            <a:spAutoFit/>
+          </a:bodyPr>
+          <a:lstStyle/>
+          <a:p>
+            <a:pPr algn="l"/>
+            <a:r>
+              <a:rPr sz="3800" b="0">
+                <a:solidFill>
+                  <a:srgbClr val="FF6B3D"/>
+                </a:solidFill>
+                <a:latin typeface="Poppins"/>
+              </a:rPr>
+              <a:t>Thousands</a:t>
+            </a:r>
+          </a:p>
+        </p:txBody>
+      </p:sp>
+      <p:sp>
+        <p:nvSpPr>
           <p:cNvPr id="130" name="TextBox 130"/>
           <p:cNvSpPr txBox="1"/>
           <p:nvPr/>
         </p:nvSpPr>
         <p:spPr>
           <a:xfrm>
-            <a:off x="6528816" y="4809744"/>
-            <a:ext cx="4681728" cy="530352"/>
+            <a:off x="6528816" y="4846320"/>
+            <a:ext cx="4681728" cy="192024"/>
           </a:xfrm>
           <a:prstGeom prst="rect">
             <a:avLst/>
@@ -11766,47 +11766,12 @@
           <a:p>
             <a:pPr algn="l"/>
             <a:r>
-              <a:rPr sz="3800" b="0">
-                <a:solidFill>
-                  <a:srgbClr val="FF6B3D"/>
+              <a:rPr sz="1400" b="0">
+                <a:solidFill>
+                  <a:srgbClr val="ECECEE"/>
                 </a:solidFill>
                 <a:latin typeface="Poppins"/>
               </a:rPr>
-              <a:t>Thousands</a:t>
-            </a:r>
-          </a:p>
-        </p:txBody>
-      </p:sp>
-      <p:sp>
-        <p:nvSpPr>
-          <p:cNvPr id="131" name="TextBox 131"/>
-          <p:cNvSpPr txBox="1"/>
-          <p:nvPr/>
-        </p:nvSpPr>
-        <p:spPr>
-          <a:xfrm>
-            <a:off x="6528816" y="5376672"/>
-            <a:ext cx="4681728" cy="192024"/>
-          </a:xfrm>
-          <a:prstGeom prst="rect">
-            <a:avLst/>
-          </a:prstGeom>
-          <a:noFill/>
-        </p:spPr>
-        <p:txBody>
-          <a:bodyPr wrap="square" lIns="0" rIns="0" tIns="0" bIns="0" anchor="ctr">
-            <a:spAutoFit/>
-          </a:bodyPr>
-          <a:lstStyle/>
-          <a:p>
-            <a:pPr algn="l"/>
-            <a:r>
-              <a:rPr sz="1400" b="0">
-                <a:solidFill>
-                  <a:srgbClr val="ECECEE"/>
-                </a:solidFill>
-                <a:latin typeface="Poppins"/>
-              </a:rPr>
               <a:t>documented anti-patterns</a:t>
             </a:r>
           </a:p>
@@ -11814,13 +11779,13 @@
       </p:sp>
       <p:sp>
         <p:nvSpPr>
-          <p:cNvPr id="132" name="rect 132"/>
+          <p:cNvPr id="131" name="rect 131"/>
           <p:cNvSpPr/>
           <p:nvPr/>
         </p:nvSpPr>
         <p:spPr>
           <a:xfrm>
-            <a:off x="694944" y="5852160"/>
+            <a:off x="694944" y="5321808"/>
             <a:ext cx="10789920" cy="10973"/>
           </a:xfrm>
           <a:prstGeom prst="rect">
@@ -11844,14 +11809,82 @@
       </p:sp>
       <p:sp>
         <p:nvSpPr>
+          <p:cNvPr id="132" name="TextBox 132"/>
+          <p:cNvSpPr txBox="1"/>
+          <p:nvPr/>
+        </p:nvSpPr>
+        <p:spPr>
+          <a:xfrm>
+            <a:off x="694944" y="5468112"/>
+            <a:ext cx="3377184" cy="182880"/>
+          </a:xfrm>
+          <a:prstGeom prst="rect">
+            <a:avLst/>
+          </a:prstGeom>
+          <a:noFill/>
+        </p:spPr>
+        <p:txBody>
+          <a:bodyPr wrap="square" lIns="0" rIns="0" tIns="0" bIns="0" anchor="ctr">
+            <a:spAutoFit/>
+          </a:bodyPr>
+          <a:lstStyle/>
+          <a:p>
+            <a:pPr algn="l"/>
+            <a:r>
+              <a:rPr sz="1300" b="1">
+                <a:solidFill>
+                  <a:srgbClr val="FF6B3D"/>
+                </a:solidFill>
+                <a:latin typeface="Poppins"/>
+              </a:rPr>
+              <a:t>Earned, not bought.</a:t>
+            </a:r>
+          </a:p>
+        </p:txBody>
+      </p:sp>
+      <p:sp>
+        <p:nvSpPr>
           <p:cNvPr id="133" name="TextBox 133"/>
           <p:cNvSpPr txBox="1"/>
           <p:nvPr/>
         </p:nvSpPr>
         <p:spPr>
           <a:xfrm>
-            <a:off x="694944" y="5998464"/>
-            <a:ext cx="10789920" cy="219456"/>
+            <a:off x="694944" y="5687568"/>
+            <a:ext cx="3377184" cy="347472"/>
+          </a:xfrm>
+          <a:prstGeom prst="rect">
+            <a:avLst/>
+          </a:prstGeom>
+          <a:noFill/>
+        </p:spPr>
+        <p:txBody>
+          <a:bodyPr wrap="square" lIns="0" rIns="0" tIns="0" bIns="0" anchor="t"/>
+          <a:lstStyle/>
+          <a:p>
+            <a:pPr algn="l"/>
+            <a:r>
+              <a:rPr sz="1100" b="0">
+                <a:solidFill>
+                  <a:srgbClr val="9A9AA2"/>
+                </a:solidFill>
+                <a:latin typeface="Poppins"/>
+              </a:rPr>
+              <a:t>The library only grows by running real production builds.</a:t>
+            </a:r>
+          </a:p>
+        </p:txBody>
+      </p:sp>
+      <p:sp>
+        <p:nvSpPr>
+          <p:cNvPr id="134" name="TextBox 134"/>
+          <p:cNvSpPr txBox="1"/>
+          <p:nvPr/>
+        </p:nvSpPr>
+        <p:spPr>
+          <a:xfrm>
+            <a:off x="4401312" y="5468112"/>
+            <a:ext cx="3377184" cy="182880"/>
           </a:xfrm>
           <a:prstGeom prst="rect">
             <a:avLst/>
@@ -11866,20 +11899,121 @@
           <a:p>
             <a:pPr algn="l"/>
             <a:r>
-              <a:rPr sz="1400" b="1">
-                <a:solidFill>
-                  <a:srgbClr val="ECECEE"/>
+              <a:rPr sz="1300" b="1">
+                <a:solidFill>
+                  <a:srgbClr val="FF6B3D"/>
                 </a:solidFill>
                 <a:latin typeface="Poppins"/>
               </a:rPr>
-              <a:t>The chain fills the library. The library makes the next chain safer. That loop is the moat.</a:t>
+              <a:t>It compounds.</a:t>
+            </a:r>
+          </a:p>
+        </p:txBody>
+      </p:sp>
+      <p:sp>
+        <p:nvSpPr>
+          <p:cNvPr id="135" name="TextBox 135"/>
+          <p:cNvSpPr txBox="1"/>
+          <p:nvPr/>
+        </p:nvSpPr>
+        <p:spPr>
+          <a:xfrm>
+            <a:off x="4401312" y="5687568"/>
+            <a:ext cx="3377184" cy="347472"/>
+          </a:xfrm>
+          <a:prstGeom prst="rect">
+            <a:avLst/>
+          </a:prstGeom>
+          <a:noFill/>
+        </p:spPr>
+        <p:txBody>
+          <a:bodyPr wrap="square" lIns="0" rIns="0" tIns="0" bIns="0" anchor="t"/>
+          <a:lstStyle/>
+          <a:p>
+            <a:pPr algn="l"/>
+            <a:r>
+              <a:rPr sz="1100" b="0">
+                <a:solidFill>
+                  <a:srgbClr val="9A9AA2"/>
+                </a:solidFill>
+                <a:latin typeface="Poppins"/>
+              </a:rPr>
+              <a:t>Every project makes the next estimate, gate and build safer.</a:t>
+            </a:r>
+          </a:p>
+        </p:txBody>
+      </p:sp>
+      <p:sp>
+        <p:nvSpPr>
+          <p:cNvPr id="136" name="TextBox 136"/>
+          <p:cNvSpPr txBox="1"/>
+          <p:nvPr/>
+        </p:nvSpPr>
+        <p:spPr>
+          <a:xfrm>
+            <a:off x="8107680" y="5468112"/>
+            <a:ext cx="3377184" cy="182880"/>
+          </a:xfrm>
+          <a:prstGeom prst="rect">
+            <a:avLst/>
+          </a:prstGeom>
+          <a:noFill/>
+        </p:spPr>
+        <p:txBody>
+          <a:bodyPr wrap="square" lIns="0" rIns="0" tIns="0" bIns="0" anchor="ctr">
+            <a:spAutoFit/>
+          </a:bodyPr>
+          <a:lstStyle/>
+          <a:p>
+            <a:pPr algn="l"/>
+            <a:r>
+              <a:rPr sz="1300" b="1">
+                <a:solidFill>
+                  <a:srgbClr val="FF6B3D"/>
+                </a:solidFill>
+                <a:latin typeface="Poppins"/>
+              </a:rPr>
+              <a:t>Capital can’t copy it.</a:t>
+            </a:r>
+          </a:p>
+        </p:txBody>
+      </p:sp>
+      <p:sp>
+        <p:nvSpPr>
+          <p:cNvPr id="137" name="TextBox 137"/>
+          <p:cNvSpPr txBox="1"/>
+          <p:nvPr/>
+        </p:nvSpPr>
+        <p:spPr>
+          <a:xfrm>
+            <a:off x="8107680" y="5687568"/>
+            <a:ext cx="3377184" cy="347472"/>
+          </a:xfrm>
+          <a:prstGeom prst="rect">
+            <a:avLst/>
+          </a:prstGeom>
+          <a:noFill/>
+        </p:spPr>
+        <p:txBody>
+          <a:bodyPr wrap="square" lIns="0" rIns="0" tIns="0" bIns="0" anchor="t"/>
+          <a:lstStyle/>
+          <a:p>
+            <a:pPr algn="l"/>
+            <a:r>
+              <a:rPr sz="1100" b="0">
+                <a:solidFill>
+                  <a:srgbClr val="9A9AA2"/>
+                </a:solidFill>
+                <a:latin typeface="Poppins"/>
+              </a:rPr>
+              <a:t>A bigger round buys code, not failures already survived.</a:t>
             </a:r>
           </a:p>
         </p:txBody>
       </p:sp>
       <p:pic>
         <p:nvPicPr>
-          <p:cNvPr id="134" name="Logo"/>
+          <p:cNvPr id="138" name="Logo"/>
           <p:cNvPicPr/>
           <p:nvPr/>
         </p:nvPicPr>

</xml_diff>